<commit_message>
glm_map: AR(4) recommendation, early AR-dependency check, sim_data note
First-level roadmap/how-to + glm_map fit:
- Recommend AR(4) over AR(1) for time-series error models (better captures
  BOLD serial autocorrelation; ~ARMA(1,1)).
- fit() now checks AR dependencies up front (fgls/Econometrics,
  aryule/Signal Processing) and errors with a clear, actionable message if
  either toolbox is missing, instead of failing mid per-voxel fit.
- Document the AR toolbox dependencies in fit.m, the roadmap, the how-to,
  and the object page.
- Note that g.is_timeseries = true also switches run_diagnostics into
  time-series mode (HP-filter cumulative-power assessment).
- Reference fmri_data.sim_data for synthetic signal+noise data (with its
  real single-predictor interface), alongside the X*betas+noise construction
  used for a custom convolved design.
- Regenerate the first-level roadmap PNG/PPTX.

Co-Authored-By: Claude Fable 5 <noreply@anthropic.com>
</commit_message>
<xml_diff>
--- a/docs/workflows/glm_map_first_level_roadmap.pptx
+++ b/docs/workflows/glm_map_first_level_roadmap.pptx
@@ -3895,7 +3895,7 @@
                 </a:solidFill>
                 <a:latin typeface="Calibri"/>
               </a:rPr>
-              <a:t>fit(g, timeseries, 'AR', 1 / 'robust')</a:t>
+              <a:t>fit(g, timeseries, 'AR', 4 / 'robust')</a:t>
             </a:r>
           </a:p>
         </p:txBody>
@@ -5198,7 +5198,7 @@
                 </a:solidFill>
                 <a:latin typeface="Calibri"/>
               </a:rPr>
-              <a:t>First-level designs are BUILT from event timing: onsets/durations are convolved with a basis set (canonical HRF by default) and stacked across runs with per-run intercepts; entered events are flagged of interest, motion / multiple_regressors as nuisance. Set g.is_timeseries = true to enable AR error models; run_diagnostics recommends a high-pass-filter cutoff (&lt; 5% variance lost) for the regressors and contrasts.</a:t>
+              <a:t>First-level designs are BUILT from event timing: onsets/durations are convolved with a basis set (canonical HRF by default) and stacked across runs with per-run intercepts; entered events are flagged of interest, motion / multiple_regressors as nuisance. Set g.is_timeseries = true to enable AR(p) error models (AR(4) recommended; needs Econometrics + Signal Processing toolboxes) and HP-filter diagnostics; run_diagnostics recommends a high-pass-filter cutoff (&lt; 5% variance lost) for the regressors and contrasts.</a:t>
             </a:r>
           </a:p>
         </p:txBody>

</xml_diff>